<commit_message>
Ajuste de estilo en la presentacion de sustentacion
- Titulos con tildes y formato natural
- Bullets mas cortos y conversacionales
- Cambio frases publicitarias por descripciones simples
- Lenguaje cercano al estudiante
</commit_message>
<xml_diff>
--- a/Entregable2/Presentacion_Sustentacion.pptx
+++ b/Entregable2/Presentacion_Sustentacion.pptx
@@ -3107,8 +3107,8 @@
         </p:nvSpPr>
         <p:spPr>
           <a:xfrm>
-            <a:off x="548640" y="2286000"/>
-            <a:ext cx="11091672" cy="1188720"/>
+            <a:off x="548640" y="2103120"/>
+            <a:ext cx="11091672" cy="1463040"/>
           </a:xfrm>
           <a:prstGeom prst="rect">
             <a:avLst/>
@@ -3123,13 +3123,14 @@
           <a:p>
             <a:pPr algn="ctr"/>
             <a:r>
-              <a:rPr b="1" sz="3800">
+              <a:rPr b="1" i="0" sz="3600">
                 <a:solidFill>
                   <a:srgbClr val="2E86AB"/>
                 </a:solidFill>
                 <a:latin typeface="Calibri"/>
               </a:rPr>
-              <a:t>Analisis Exploratorio y Modelamiento Supervisado</a:t>
+              <a:t>Análisis Exploratorio y Modelamiento del
+Dataset Heart Disease</a:t>
             </a:r>
           </a:p>
         </p:txBody>
@@ -3142,8 +3143,8 @@
         </p:nvSpPr>
         <p:spPr>
           <a:xfrm>
-            <a:off x="548640" y="3383280"/>
-            <a:ext cx="11091672" cy="640080"/>
+            <a:off x="548640" y="3657600"/>
+            <a:ext cx="11091672" cy="548640"/>
           </a:xfrm>
           <a:prstGeom prst="rect">
             <a:avLst/>
@@ -3151,20 +3152,20 @@
           <a:noFill/>
         </p:spPr>
         <p:txBody>
-          <a:bodyPr wrap="none">
+          <a:bodyPr wrap="square">
             <a:spAutoFit/>
           </a:bodyPr>
           <a:lstStyle/>
           <a:p>
             <a:pPr algn="ctr"/>
             <a:r>
-              <a:rPr sz="2200" i="1">
+              <a:rPr b="0" i="1" sz="2000">
                 <a:solidFill>
                   <a:srgbClr val="222222"/>
                 </a:solidFill>
                 <a:latin typeface="Calibri"/>
               </a:rPr>
-              <a:t>Dataset Heart Disease - UCI Machine Learning Repository</a:t>
+              <a:t>Proyecto final – Seminario de Ciencia de Datos</a:t>
             </a:r>
           </a:p>
         </p:txBody>
@@ -3177,8 +3178,8 @@
         </p:nvSpPr>
         <p:spPr>
           <a:xfrm>
-            <a:off x="548640" y="5029200"/>
-            <a:ext cx="11091672" cy="1371600"/>
+            <a:off x="548640" y="4846320"/>
+            <a:ext cx="11091672" cy="457200"/>
           </a:xfrm>
           <a:prstGeom prst="rect">
             <a:avLst/>
@@ -3193,7 +3194,7 @@
           <a:p>
             <a:pPr algn="ctr"/>
             <a:r>
-              <a:rPr sz="1600" b="1">
+              <a:rPr b="1" i="0" sz="1800">
                 <a:solidFill>
                   <a:srgbClr val="222222"/>
                 </a:solidFill>
@@ -3202,28 +3203,74 @@
               <a:t>Jaime Alzate</a:t>
             </a:r>
           </a:p>
+        </p:txBody>
+      </p:sp>
+      <p:sp>
+        <p:nvSpPr>
+          <p:cNvPr id="5" name="TextBox 4"/>
+          <p:cNvSpPr txBox="1"/>
+          <p:nvPr/>
+        </p:nvSpPr>
+        <p:spPr>
+          <a:xfrm>
+            <a:off x="548640" y="5349240"/>
+            <a:ext cx="11091672" cy="365760"/>
+          </a:xfrm>
+          <a:prstGeom prst="rect">
+            <a:avLst/>
+          </a:prstGeom>
+          <a:noFill/>
+        </p:spPr>
+        <p:txBody>
+          <a:bodyPr wrap="square">
+            <a:spAutoFit/>
+          </a:bodyPr>
+          <a:lstStyle/>
           <a:p>
             <a:pPr algn="ctr"/>
             <a:r>
-              <a:rPr sz="1600">
+              <a:rPr b="0" i="0" sz="1500">
                 <a:solidFill>
                   <a:srgbClr val="222222"/>
                 </a:solidFill>
                 <a:latin typeface="Calibri"/>
               </a:rPr>
-              <a:t>Programa de Desarrollo de Software - Noveno Semestre</a:t>
-            </a:r>
-          </a:p>
+              <a:t>Desarrollo de Software – 9° semestre</a:t>
+            </a:r>
+          </a:p>
+        </p:txBody>
+      </p:sp>
+      <p:sp>
+        <p:nvSpPr>
+          <p:cNvPr id="6" name="TextBox 5"/>
+          <p:cNvSpPr txBox="1"/>
+          <p:nvPr/>
+        </p:nvSpPr>
+        <p:spPr>
+          <a:xfrm>
+            <a:off x="548640" y="5715000"/>
+            <a:ext cx="11091672" cy="365760"/>
+          </a:xfrm>
+          <a:prstGeom prst="rect">
+            <a:avLst/>
+          </a:prstGeom>
+          <a:noFill/>
+        </p:spPr>
+        <p:txBody>
+          <a:bodyPr wrap="square">
+            <a:spAutoFit/>
+          </a:bodyPr>
+          <a:lstStyle/>
           <a:p>
             <a:pPr algn="ctr"/>
             <a:r>
-              <a:rPr sz="1600">
+              <a:rPr b="0" i="0" sz="1500">
                 <a:solidFill>
                   <a:srgbClr val="222222"/>
                 </a:solidFill>
                 <a:latin typeface="Calibri"/>
               </a:rPr>
-              <a:t>Seminario de Ciencia de los Datos | Mayo 2026</a:t>
+              <a:t>Mayo de 2026</a:t>
             </a:r>
           </a:p>
         </p:txBody>
@@ -3270,13 +3317,13 @@
           <a:p>
             <a:pPr algn="l"/>
             <a:r>
-              <a:rPr b="1" sz="3200">
-                <a:solidFill>
-                  <a:srgbClr val="222222"/>
-                </a:solidFill>
-                <a:latin typeface="Calibri"/>
-              </a:rPr>
-              <a:t>VIII. Comparacion de metricas</a:t>
+              <a:rPr b="1" i="0" sz="3200">
+                <a:solidFill>
+                  <a:srgbClr val="2E86AB"/>
+                </a:solidFill>
+                <a:latin typeface="Calibri"/>
+              </a:rPr>
+              <a:t>Comparación de las métricas</a:t>
             </a:r>
           </a:p>
         </p:txBody>
@@ -3290,7 +3337,7 @@
         <p:spPr>
           <a:xfrm>
             <a:off x="548640" y="1005840"/>
-            <a:ext cx="11091672" cy="777240"/>
+            <a:ext cx="11091672" cy="457200"/>
           </a:xfrm>
           <a:prstGeom prst="rect">
             <a:avLst/>
@@ -3305,13 +3352,13 @@
           <a:p>
             <a:pPr algn="l"/>
             <a:r>
-              <a:rPr b="0" sz="1800">
-                <a:solidFill>
-                  <a:srgbClr val="2E86AB"/>
-                </a:solidFill>
-                <a:latin typeface="Calibri"/>
-              </a:rPr>
-              <a:t>Logistica gana en todas las metricas + menor varianza en CV</a:t>
+              <a:rPr b="0" i="0" sz="1800">
+                <a:solidFill>
+                  <a:srgbClr val="A23B72"/>
+                </a:solidFill>
+                <a:latin typeface="Calibri"/>
+              </a:rPr>
+              <a:t>La logística gana en las 5 métricas + es más estable en CV</a:t>
             </a:r>
           </a:p>
         </p:txBody>
@@ -3325,7 +3372,7 @@
           <p:nvPr/>
         </p:nvGraphicFramePr>
         <p:xfrm>
-          <a:off x="1371600" y="1645920"/>
+          <a:off x="1371600" y="1783080"/>
           <a:ext cx="9418320" cy="4114800"/>
         </p:xfrm>
         <a:graphic>
@@ -3354,7 +3401,7 @@
                           </a:solidFill>
                           <a:latin typeface="Calibri"/>
                         </a:rPr>
-                        <a:t>Metrica</a:t>
+                        <a:t>Métrica</a:t>
                       </a:r>
                     </a:p>
                   </a:txBody>
@@ -3377,7 +3424,7 @@
                           </a:solidFill>
                           <a:latin typeface="Calibri"/>
                         </a:rPr>
-                        <a:t>Regresion Logistica</a:t>
+                        <a:t>Reg. Logística</a:t>
                       </a:r>
                     </a:p>
                   </a:txBody>
@@ -3400,7 +3447,7 @@
                           </a:solidFill>
                           <a:latin typeface="Calibri"/>
                         </a:rPr>
-                        <a:t>Arbol de Decision</a:t>
+                        <a:t>Árbol</a:t>
                       </a:r>
                     </a:p>
                   </a:txBody>
@@ -3505,7 +3552,7 @@
                           </a:solidFill>
                           <a:latin typeface="Calibri"/>
                         </a:rPr>
-                        <a:t>Logistica</a:t>
+                        <a:t>Logística</a:t>
                       </a:r>
                     </a:p>
                   </a:txBody>
@@ -3583,7 +3630,7 @@
                           </a:solidFill>
                           <a:latin typeface="Calibri"/>
                         </a:rPr>
-                        <a:t>Logistica</a:t>
+                        <a:t>Logística</a:t>
                       </a:r>
                     </a:p>
                   </a:txBody>
@@ -3661,7 +3708,7 @@
                           </a:solidFill>
                           <a:latin typeface="Calibri"/>
                         </a:rPr>
-                        <a:t>Logistica</a:t>
+                        <a:t>Logística</a:t>
                       </a:r>
                     </a:p>
                   </a:txBody>
@@ -3739,7 +3786,7 @@
                           </a:solidFill>
                           <a:latin typeface="Calibri"/>
                         </a:rPr>
-                        <a:t>Logistica</a:t>
+                        <a:t>Logística</a:t>
                       </a:r>
                     </a:p>
                   </a:txBody>
@@ -3817,7 +3864,7 @@
                           </a:solidFill>
                           <a:latin typeface="Calibri"/>
                         </a:rPr>
-                        <a:t>Logistica</a:t>
+                        <a:t>Logística</a:t>
                       </a:r>
                     </a:p>
                   </a:txBody>
@@ -3857,7 +3904,7 @@
                           </a:solidFill>
                           <a:latin typeface="Calibri"/>
                         </a:rPr>
-                        <a:t>0.8263 ± 0.05</a:t>
+                        <a:t>0.83 ± 0.05</a:t>
                       </a:r>
                     </a:p>
                   </a:txBody>
@@ -3876,7 +3923,7 @@
                           </a:solidFill>
                           <a:latin typeface="Calibri"/>
                         </a:rPr>
-                        <a:t>0.7151 ± 0.06</a:t>
+                        <a:t>0.72 ± 0.06</a:t>
                       </a:r>
                     </a:p>
                   </a:txBody>
@@ -3895,7 +3942,7 @@
                           </a:solidFill>
                           <a:latin typeface="Calibri"/>
                         </a:rPr>
-                        <a:t>Logistica</a:t>
+                        <a:t>Logística</a:t>
                       </a:r>
                     </a:p>
                   </a:txBody>
@@ -3923,17 +3970,18 @@
           <a:noFill/>
         </p:spPr>
         <p:txBody>
-          <a:bodyPr wrap="none">
+          <a:bodyPr wrap="square">
             <a:spAutoFit/>
           </a:bodyPr>
           <a:lstStyle/>
           <a:p>
             <a:pPr algn="r"/>
             <a:r>
-              <a:rPr sz="1100">
+              <a:rPr b="0" i="0" sz="1100">
                 <a:solidFill>
                   <a:srgbClr val="2E86AB"/>
                 </a:solidFill>
+                <a:latin typeface="Calibri"/>
               </a:rPr>
               <a:t>10 / 12</a:t>
             </a:r>
@@ -3982,13 +4030,13 @@
           <a:p>
             <a:pPr algn="l"/>
             <a:r>
-              <a:rPr b="1" sz="3200">
-                <a:solidFill>
-                  <a:srgbClr val="222222"/>
-                </a:solidFill>
-                <a:latin typeface="Calibri"/>
-              </a:rPr>
-              <a:t>VIII. Coherencia entre modelos y filtro</a:t>
+              <a:rPr b="1" i="0" sz="3200">
+                <a:solidFill>
+                  <a:srgbClr val="2E86AB"/>
+                </a:solidFill>
+                <a:latin typeface="Calibri"/>
+              </a:rPr>
+              <a:t>Algo interesante</a:t>
             </a:r>
           </a:p>
         </p:txBody>
@@ -4002,7 +4050,7 @@
         <p:spPr>
           <a:xfrm>
             <a:off x="548640" y="1005840"/>
-            <a:ext cx="11091672" cy="777240"/>
+            <a:ext cx="11091672" cy="457200"/>
           </a:xfrm>
           <a:prstGeom prst="rect">
             <a:avLst/>
@@ -4017,20 +4065,20 @@
           <a:p>
             <a:pPr algn="l"/>
             <a:r>
-              <a:rPr b="0" sz="1800">
-                <a:solidFill>
-                  <a:srgbClr val="2E86AB"/>
-                </a:solidFill>
-                <a:latin typeface="Calibri"/>
-              </a:rPr>
-              <a:t>Ambos modelos priorizan las variables identificadas por correlacion</a:t>
+              <a:rPr b="0" i="0" sz="1800">
+                <a:solidFill>
+                  <a:srgbClr val="A23B72"/>
+                </a:solidFill>
+                <a:latin typeface="Calibri"/>
+              </a:rPr>
+              <a:t>Los modelos coinciden en qué variables son las más importantes</a:t>
             </a:r>
           </a:p>
         </p:txBody>
       </p:sp>
       <p:pic>
         <p:nvPicPr>
-          <p:cNvPr id="4" name="Picture 3" descr="07_importancia_variables.png"/>
+          <p:cNvPr id="4" name="Picture 3" descr="07_importancia.png"/>
           <p:cNvPicPr>
             <a:picLocks noChangeAspect="1"/>
           </p:cNvPicPr>
@@ -4044,8 +4092,8 @@
         </p:blipFill>
         <p:spPr>
           <a:xfrm>
-            <a:off x="548640" y="1554480"/>
-            <a:ext cx="11064240" cy="3838497"/>
+            <a:off x="548640" y="1600200"/>
+            <a:ext cx="11064240" cy="3849921"/>
           </a:xfrm>
           <a:prstGeom prst="rect">
             <a:avLst/>
@@ -4069,17 +4117,18 @@
           <a:noFill/>
         </p:spPr>
         <p:txBody>
-          <a:bodyPr wrap="none">
+          <a:bodyPr wrap="square">
             <a:spAutoFit/>
           </a:bodyPr>
           <a:lstStyle/>
           <a:p>
             <a:pPr algn="r"/>
             <a:r>
-              <a:rPr sz="1100">
+              <a:rPr b="0" i="0" sz="1100">
                 <a:solidFill>
                   <a:srgbClr val="2E86AB"/>
                 </a:solidFill>
+                <a:latin typeface="Calibri"/>
               </a:rPr>
               <a:t>11 / 12</a:t>
             </a:r>
@@ -4128,13 +4177,13 @@
           <a:p>
             <a:pPr algn="l"/>
             <a:r>
-              <a:rPr b="1" sz="3200">
-                <a:solidFill>
-                  <a:srgbClr val="222222"/>
-                </a:solidFill>
-                <a:latin typeface="Calibri"/>
-              </a:rPr>
-              <a:t>IX. Conclusiones y trabajo futuro</a:t>
+              <a:rPr b="1" i="0" sz="3200">
+                <a:solidFill>
+                  <a:srgbClr val="2E86AB"/>
+                </a:solidFill>
+                <a:latin typeface="Calibri"/>
+              </a:rPr>
+              <a:t>Conclusiones y lo que falta</a:t>
             </a:r>
           </a:p>
         </p:txBody>
@@ -4148,7 +4197,7 @@
         <p:spPr>
           <a:xfrm>
             <a:off x="548640" y="1005840"/>
-            <a:ext cx="11091672" cy="777240"/>
+            <a:ext cx="11091672" cy="457200"/>
           </a:xfrm>
           <a:prstGeom prst="rect">
             <a:avLst/>
@@ -4163,13 +4212,13 @@
           <a:p>
             <a:pPr algn="l"/>
             <a:r>
-              <a:rPr b="0" sz="1800">
-                <a:solidFill>
-                  <a:srgbClr val="2E86AB"/>
-                </a:solidFill>
-                <a:latin typeface="Calibri"/>
-              </a:rPr>
-              <a:t>El preprocesamiento riguroso + modelo lineal = clasificador clinicamente util</a:t>
+              <a:rPr b="0" i="0" sz="1800">
+                <a:solidFill>
+                  <a:srgbClr val="A23B72"/>
+                </a:solidFill>
+                <a:latin typeface="Calibri"/>
+              </a:rPr>
+              <a:t>Lo que aprendí y lo que haría diferente</a:t>
             </a:r>
           </a:p>
         </p:txBody>
@@ -4182,8 +4231,8 @@
         </p:nvSpPr>
         <p:spPr>
           <a:xfrm>
-            <a:off x="640080" y="1554480"/>
-            <a:ext cx="10972800" cy="4754880"/>
+            <a:off x="640080" y="1691640"/>
+            <a:ext cx="10972800" cy="4572000"/>
           </a:xfrm>
           <a:prstGeom prst="rect">
             <a:avLst/>
@@ -4198,7 +4247,7 @@
           <a:p>
             <a:pPr algn="l">
               <a:spcAft>
-                <a:spcPts val="1000"/>
+                <a:spcPts val="800"/>
               </a:spcAft>
             </a:pPr>
             <a:r>
@@ -4208,13 +4257,13 @@
                 </a:solidFill>
                 <a:latin typeface="Calibri"/>
               </a:rPr>
-              <a:t>  •  PCA: 8 componentes explican 80% de la varianza; PC1 = severidad cardiaca</a:t>
+              <a:t>  •  Con PCA pude reducir de 13 a 8 variables (38% menos) y mantener el 80% de la varianza</a:t>
             </a:r>
           </a:p>
           <a:p>
             <a:pPr algn="l">
               <a:spcAft>
-                <a:spcPts val="1000"/>
+                <a:spcPts val="800"/>
               </a:spcAft>
             </a:pPr>
             <a:r>
@@ -4224,13 +4273,13 @@
                 </a:solidFill>
                 <a:latin typeface="Calibri"/>
               </a:rPr>
-              <a:t>  •  Top 5 features (thal, ca, exang, oldpeak, thalach) coherentes con la literatura</a:t>
+              <a:t>  •  Las 5 variables del filtro coinciden con lo que dice la literatura médica</a:t>
             </a:r>
           </a:p>
           <a:p>
             <a:pPr algn="l">
               <a:spcAft>
-                <a:spcPts val="1000"/>
+                <a:spcPts val="800"/>
               </a:spcAft>
             </a:pPr>
             <a:r>
@@ -4240,13 +4289,13 @@
                 </a:solidFill>
                 <a:latin typeface="Calibri"/>
               </a:rPr>
-              <a:t>  •  Regresion Logistica gana: accuracy 0.85, F1 0.85, ROC-AUC 0.95</a:t>
+              <a:t>  •  La Regresión Logística ganó: accuracy 0.85, F1 0.85, ROC-AUC 0.95</a:t>
             </a:r>
           </a:p>
           <a:p>
             <a:pPr algn="l">
               <a:spcAft>
-                <a:spcPts val="1000"/>
+                <a:spcPts val="800"/>
               </a:spcAft>
             </a:pPr>
             <a:r>
@@ -4256,13 +4305,13 @@
                 </a:solidFill>
                 <a:latin typeface="Calibri"/>
               </a:rPr>
-              <a:t>  •  Capping + imputacion bayesiana del Entregable 1 fueron criticos para el desempeno</a:t>
+              <a:t>  •  El preprocesamiento del Entregable 1 sí impactó el resultado final</a:t>
             </a:r>
           </a:p>
           <a:p>
             <a:pPr algn="l">
               <a:spcAft>
-                <a:spcPts val="1000"/>
+                <a:spcPts val="800"/>
               </a:spcAft>
             </a:pPr>
             <a:r>
@@ -4272,13 +4321,13 @@
                 </a:solidFill>
                 <a:latin typeface="Calibri"/>
               </a:rPr>
-              <a:t>  •  Trabajo futuro: validar en cohortes Hungarian/Switzerland + ensamble (Random Forest, XGBoost) + explicabilidad SHAP</a:t>
+              <a:t>  •  Trabajo futuro: probar con Random Forest, validar en otros datasets (Hungarian, Switzerland)</a:t>
             </a:r>
           </a:p>
           <a:p>
             <a:pPr algn="l">
               <a:spcAft>
-                <a:spcPts val="1000"/>
+                <a:spcPts val="800"/>
               </a:spcAft>
             </a:pPr>
             <a:r>
@@ -4288,7 +4337,7 @@
                 </a:solidFill>
                 <a:latin typeface="Calibri"/>
               </a:rPr>
-              <a:t>  •  Repositorio publicado en GitHub para el componente de deployment</a:t>
+              <a:t>  •  Código publicado en GitHub: github.com/JAAM010/seminario-datos-heart-disease</a:t>
             </a:r>
           </a:p>
         </p:txBody>
@@ -4310,17 +4359,18 @@
           <a:noFill/>
         </p:spPr>
         <p:txBody>
-          <a:bodyPr wrap="none">
+          <a:bodyPr wrap="square">
             <a:spAutoFit/>
           </a:bodyPr>
           <a:lstStyle/>
           <a:p>
             <a:pPr algn="r"/>
             <a:r>
-              <a:rPr sz="1100">
+              <a:rPr b="0" i="0" sz="1100">
                 <a:solidFill>
                   <a:srgbClr val="2E86AB"/>
                 </a:solidFill>
+                <a:latin typeface="Calibri"/>
               </a:rPr>
               <a:t>12 / 12</a:t>
             </a:r>
@@ -4369,13 +4419,13 @@
           <a:p>
             <a:pPr algn="l"/>
             <a:r>
-              <a:rPr b="1" sz="3200">
-                <a:solidFill>
-                  <a:srgbClr val="222222"/>
-                </a:solidFill>
-                <a:latin typeface="Calibri"/>
-              </a:rPr>
-              <a:t>Problema y dataset</a:t>
+              <a:rPr b="1" i="0" sz="3200">
+                <a:solidFill>
+                  <a:srgbClr val="2E86AB"/>
+                </a:solidFill>
+                <a:latin typeface="Calibri"/>
+              </a:rPr>
+              <a:t>¿De qué se trata el proyecto?</a:t>
             </a:r>
           </a:p>
         </p:txBody>
@@ -4389,7 +4439,7 @@
         <p:spPr>
           <a:xfrm>
             <a:off x="548640" y="1005840"/>
-            <a:ext cx="11091672" cy="777240"/>
+            <a:ext cx="11091672" cy="457200"/>
           </a:xfrm>
           <a:prstGeom prst="rect">
             <a:avLst/>
@@ -4404,13 +4454,13 @@
           <a:p>
             <a:pPr algn="l"/>
             <a:r>
-              <a:rPr b="0" sz="1800">
-                <a:solidFill>
-                  <a:srgbClr val="2E86AB"/>
-                </a:solidFill>
-                <a:latin typeface="Calibri"/>
-              </a:rPr>
-              <a:t>Apoyar la deteccion temprana de enfermedad coronaria con datos clinicos no invasivos</a:t>
+              <a:rPr b="0" i="0" sz="1800">
+                <a:solidFill>
+                  <a:srgbClr val="A23B72"/>
+                </a:solidFill>
+                <a:latin typeface="Calibri"/>
+              </a:rPr>
+              <a:t>Predecir enfermedad cardíaca con datos clínicos del paciente</a:t>
             </a:r>
           </a:p>
         </p:txBody>
@@ -4423,8 +4473,8 @@
         </p:nvSpPr>
         <p:spPr>
           <a:xfrm>
-            <a:off x="640080" y="1554480"/>
-            <a:ext cx="10972800" cy="4754880"/>
+            <a:off x="640080" y="1691640"/>
+            <a:ext cx="10972800" cy="4572000"/>
           </a:xfrm>
           <a:prstGeom prst="rect">
             <a:avLst/>
@@ -4439,7 +4489,7 @@
           <a:p>
             <a:pPr algn="l">
               <a:spcAft>
-                <a:spcPts val="1000"/>
+                <a:spcPts val="800"/>
               </a:spcAft>
             </a:pPr>
             <a:r>
@@ -4449,13 +4499,13 @@
                 </a:solidFill>
                 <a:latin typeface="Calibri"/>
               </a:rPr>
-              <a:t>  •  Dataset Heart Disease (Cleveland) del UCI ML Repository</a:t>
+              <a:t>  •  Dataset: Heart Disease (Cleveland) del UCI – 303 pacientes y 14 variables</a:t>
             </a:r>
           </a:p>
           <a:p>
             <a:pPr algn="l">
               <a:spcAft>
-                <a:spcPts val="1000"/>
+                <a:spcPts val="800"/>
               </a:spcAft>
             </a:pPr>
             <a:r>
@@ -4465,13 +4515,13 @@
                 </a:solidFill>
                 <a:latin typeface="Calibri"/>
               </a:rPr>
-              <a:t>  •  303 observaciones x 14 variables (13 predictoras + 1 objetivo)</a:t>
+              <a:t>  •  Tema de salud: las enfermedades del corazón son la primera causa de muerte en el mundo</a:t>
             </a:r>
           </a:p>
           <a:p>
             <a:pPr algn="l">
               <a:spcAft>
-                <a:spcPts val="1000"/>
+                <a:spcPts val="800"/>
               </a:spcAft>
             </a:pPr>
             <a:r>
@@ -4481,13 +4531,13 @@
                 </a:solidFill>
                 <a:latin typeface="Calibri"/>
               </a:rPr>
-              <a:t>  •  Variable objetivo: presencia o no de enfermedad cardiaca (binaria)</a:t>
+              <a:t>  •  El target es binario: 0 = sin enfermedad, 1 = con enfermedad</a:t>
             </a:r>
           </a:p>
           <a:p>
             <a:pPr algn="l">
               <a:spcAft>
-                <a:spcPts val="1000"/>
+                <a:spcPts val="800"/>
               </a:spcAft>
             </a:pPr>
             <a:r>
@@ -4497,13 +4547,13 @@
                 </a:solidFill>
                 <a:latin typeface="Calibri"/>
               </a:rPr>
-              <a:t>  •  Retos identificados: nulos codificados como '?', outliers en colesterol y presion, variables categoricas codificadas como numericas</a:t>
+              <a:t>  •  Cumple lo que pidió el profesor: tiene nulos, outliers y más de 10 variables</a:t>
             </a:r>
           </a:p>
           <a:p>
             <a:pPr algn="l">
               <a:spcAft>
-                <a:spcPts val="1000"/>
+                <a:spcPts val="800"/>
               </a:spcAft>
             </a:pPr>
             <a:r>
@@ -4513,7 +4563,7 @@
                 </a:solidFill>
                 <a:latin typeface="Calibri"/>
               </a:rPr>
-              <a:t>  •  Justifica PCA por dimensionalidad y correlaciones internas entre features clinicas</a:t>
+              <a:t>  •  Por la cantidad de variables y correlaciones tiene sentido aplicar PCA</a:t>
             </a:r>
           </a:p>
         </p:txBody>
@@ -4535,17 +4585,18 @@
           <a:noFill/>
         </p:spPr>
         <p:txBody>
-          <a:bodyPr wrap="none">
+          <a:bodyPr wrap="square">
             <a:spAutoFit/>
           </a:bodyPr>
           <a:lstStyle/>
           <a:p>
             <a:pPr algn="r"/>
             <a:r>
-              <a:rPr sz="1100">
+              <a:rPr b="0" i="0" sz="1100">
                 <a:solidFill>
                   <a:srgbClr val="2E86AB"/>
                 </a:solidFill>
+                <a:latin typeface="Calibri"/>
               </a:rPr>
               <a:t>2 / 12</a:t>
             </a:r>
@@ -4594,13 +4645,13 @@
           <a:p>
             <a:pPr algn="l"/>
             <a:r>
-              <a:rPr b="1" sz="3200">
-                <a:solidFill>
-                  <a:srgbClr val="222222"/>
-                </a:solidFill>
-                <a:latin typeface="Calibri"/>
-              </a:rPr>
-              <a:t>Metodologia CRISP-DM aplicada</a:t>
+              <a:rPr b="1" i="0" sz="3200">
+                <a:solidFill>
+                  <a:srgbClr val="2E86AB"/>
+                </a:solidFill>
+                <a:latin typeface="Calibri"/>
+              </a:rPr>
+              <a:t>Metodología: CRISP-DM</a:t>
             </a:r>
           </a:p>
         </p:txBody>
@@ -4614,7 +4665,7 @@
         <p:spPr>
           <a:xfrm>
             <a:off x="548640" y="1005840"/>
-            <a:ext cx="11091672" cy="777240"/>
+            <a:ext cx="11091672" cy="457200"/>
           </a:xfrm>
           <a:prstGeom prst="rect">
             <a:avLst/>
@@ -4629,13 +4680,13 @@
           <a:p>
             <a:pPr algn="l"/>
             <a:r>
-              <a:rPr b="0" sz="1800">
-                <a:solidFill>
-                  <a:srgbClr val="2E86AB"/>
-                </a:solidFill>
-                <a:latin typeface="Calibri"/>
-              </a:rPr>
-              <a:t>Recorrido completo de las 5 fases del proceso de mineria de datos</a:t>
+              <a:rPr b="0" i="0" sz="1800">
+                <a:solidFill>
+                  <a:srgbClr val="A23B72"/>
+                </a:solidFill>
+                <a:latin typeface="Calibri"/>
+              </a:rPr>
+              <a:t>El proceso estándar de ciencia de datos, lo que vimos en clase</a:t>
             </a:r>
           </a:p>
         </p:txBody>
@@ -4648,8 +4699,8 @@
         </p:nvSpPr>
         <p:spPr>
           <a:xfrm>
-            <a:off x="640080" y="1554480"/>
-            <a:ext cx="10972800" cy="4754880"/>
+            <a:off x="640080" y="1691640"/>
+            <a:ext cx="10972800" cy="4572000"/>
           </a:xfrm>
           <a:prstGeom prst="rect">
             <a:avLst/>
@@ -4664,7 +4715,7 @@
           <a:p>
             <a:pPr algn="l">
               <a:spcAft>
-                <a:spcPts val="1000"/>
+                <a:spcPts val="800"/>
               </a:spcAft>
             </a:pPr>
             <a:r>
@@ -4674,13 +4725,13 @@
                 </a:solidFill>
                 <a:latin typeface="Calibri"/>
               </a:rPr>
-              <a:t>  •  1. Comprension del negocio: diagnostico clinico apoyado por ML</a:t>
+              <a:t>  •  1. Entender el negocio: ayudar al diagnóstico clínico</a:t>
             </a:r>
           </a:p>
           <a:p>
             <a:pPr algn="l">
               <a:spcAft>
-                <a:spcPts val="1000"/>
+                <a:spcPts val="800"/>
               </a:spcAft>
             </a:pPr>
             <a:r>
@@ -4690,13 +4741,13 @@
                 </a:solidFill>
                 <a:latin typeface="Calibri"/>
               </a:rPr>
-              <a:t>  •  2. Comprension de los datos: 303 registros, 14 features, calidad deficiente</a:t>
+              <a:t>  •  2. Entender los datos: dataset clínico, calidad regular</a:t>
             </a:r>
           </a:p>
           <a:p>
             <a:pPr algn="l">
               <a:spcAft>
-                <a:spcPts val="1000"/>
+                <a:spcPts val="800"/>
               </a:spcAft>
             </a:pPr>
             <a:r>
@@ -4706,13 +4757,13 @@
                 </a:solidFill>
                 <a:latin typeface="Calibri"/>
               </a:rPr>
-              <a:t>  •  3. Preparacion: capping por IQR + imputacion bayesiana (Entregable 1)</a:t>
+              <a:t>  •  3. Preparar los datos: limpieza + imputación (Entregable 1)</a:t>
             </a:r>
           </a:p>
           <a:p>
             <a:pPr algn="l">
               <a:spcAft>
-                <a:spcPts val="1000"/>
+                <a:spcPts val="800"/>
               </a:spcAft>
             </a:pPr>
             <a:r>
@@ -4722,13 +4773,13 @@
                 </a:solidFill>
                 <a:latin typeface="Calibri"/>
               </a:rPr>
-              <a:t>  •  4. Modelado: PCA + seleccion por correlacion + 2 modelos supervisados (Entregable 2)</a:t>
+              <a:t>  •  4. Modelar: PCA + filtro de variables + 2 modelos (Entregable 2)</a:t>
             </a:r>
           </a:p>
           <a:p>
             <a:pPr algn="l">
               <a:spcAft>
-                <a:spcPts val="1000"/>
+                <a:spcPts val="800"/>
               </a:spcAft>
             </a:pPr>
             <a:r>
@@ -4738,7 +4789,7 @@
                 </a:solidFill>
                 <a:latin typeface="Calibri"/>
               </a:rPr>
-              <a:t>  •  5. Evaluacion: accuracy, F1, ROC-AUC, validacion cruzada 5-fold</a:t>
+              <a:t>  •  5. Evaluar: accuracy, F1, ROC-AUC, validación cruzada</a:t>
             </a:r>
           </a:p>
         </p:txBody>
@@ -4760,17 +4811,18 @@
           <a:noFill/>
         </p:spPr>
         <p:txBody>
-          <a:bodyPr wrap="none">
+          <a:bodyPr wrap="square">
             <a:spAutoFit/>
           </a:bodyPr>
           <a:lstStyle/>
           <a:p>
             <a:pPr algn="r"/>
             <a:r>
-              <a:rPr sz="1100">
+              <a:rPr b="0" i="0" sz="1100">
                 <a:solidFill>
                   <a:srgbClr val="2E86AB"/>
                 </a:solidFill>
+                <a:latin typeface="Calibri"/>
               </a:rPr>
               <a:t>3 / 12</a:t>
             </a:r>
@@ -4819,13 +4871,13 @@
           <a:p>
             <a:pPr algn="l"/>
             <a:r>
-              <a:rPr b="1" sz="3200">
-                <a:solidFill>
-                  <a:srgbClr val="222222"/>
-                </a:solidFill>
-                <a:latin typeface="Calibri"/>
-              </a:rPr>
-              <a:t>Entregable 1 - Resumen del preprocesamiento</a:t>
+              <a:rPr b="1" i="0" sz="3200">
+                <a:solidFill>
+                  <a:srgbClr val="2E86AB"/>
+                </a:solidFill>
+                <a:latin typeface="Calibri"/>
+              </a:rPr>
+              <a:t>Recap del Entregable 1</a:t>
             </a:r>
           </a:p>
         </p:txBody>
@@ -4839,7 +4891,7 @@
         <p:spPr>
           <a:xfrm>
             <a:off x="548640" y="1005840"/>
-            <a:ext cx="11091672" cy="777240"/>
+            <a:ext cx="11091672" cy="457200"/>
           </a:xfrm>
           <a:prstGeom prst="rect">
             <a:avLst/>
@@ -4854,13 +4906,13 @@
           <a:p>
             <a:pPr algn="l"/>
             <a:r>
-              <a:rPr b="0" sz="1800">
-                <a:solidFill>
-                  <a:srgbClr val="2E86AB"/>
-                </a:solidFill>
-                <a:latin typeface="Calibri"/>
-              </a:rPr>
-              <a:t>Calidad de datos: 6 nulos tratados y 40 outliers controlados sin perder filas</a:t>
+              <a:rPr b="0" i="0" sz="1800">
+                <a:solidFill>
+                  <a:srgbClr val="A23B72"/>
+                </a:solidFill>
+                <a:latin typeface="Calibri"/>
+              </a:rPr>
+              <a:t>Lo que hice antes de modelar</a:t>
             </a:r>
           </a:p>
         </p:txBody>
@@ -4873,8 +4925,8 @@
         </p:nvSpPr>
         <p:spPr>
           <a:xfrm>
-            <a:off x="640080" y="1554480"/>
-            <a:ext cx="10972800" cy="4754880"/>
+            <a:off x="640080" y="1691640"/>
+            <a:ext cx="10972800" cy="4572000"/>
           </a:xfrm>
           <a:prstGeom prst="rect">
             <a:avLst/>
@@ -4889,7 +4941,7 @@
           <a:p>
             <a:pPr algn="l">
               <a:spcAft>
-                <a:spcPts val="1000"/>
+                <a:spcPts val="800"/>
               </a:spcAft>
             </a:pPr>
             <a:r>
@@ -4899,13 +4951,13 @@
                 </a:solidFill>
                 <a:latin typeface="Calibri"/>
               </a:rPr>
-              <a:t>  •  Normalidad rechazada por Shapiro-Wilk en las 6 variables continuas (p &lt;&lt; 0.05)</a:t>
+              <a:t>  •  Apliqué Shapiro-Wilk: ninguna de las 6 variables continuas es normal (p &lt; 0.05)</a:t>
             </a:r>
           </a:p>
           <a:p>
             <a:pPr algn="l">
               <a:spcAft>
-                <a:spcPts val="1000"/>
+                <a:spcPts val="800"/>
               </a:spcAft>
             </a:pPr>
             <a:r>
@@ -4915,13 +4967,13 @@
                 </a:solidFill>
                 <a:latin typeface="Calibri"/>
               </a:rPr>
-              <a:t>  •  Nulos: 4 en 'ca' y 2 en 'thal'. Prueba de rachas: patron MAR en 'ca'</a:t>
+              <a:t>  •  Encontré 6 nulos: 4 en ca y 2 en thal</a:t>
             </a:r>
           </a:p>
           <a:p>
             <a:pPr algn="l">
               <a:spcAft>
-                <a:spcPts val="1000"/>
+                <a:spcPts val="800"/>
               </a:spcAft>
             </a:pPr>
             <a:r>
@@ -4931,13 +4983,13 @@
                 </a:solidFill>
                 <a:latin typeface="Calibri"/>
               </a:rPr>
-              <a:t>  •  Outliers detectados por IQR: 40 en total. Tratamiento por capping (sin perder filas)</a:t>
+              <a:t>  •  La prueba de rachas mostró que los nulos de ca no son aleatorios</a:t>
             </a:r>
           </a:p>
           <a:p>
             <a:pPr algn="l">
               <a:spcAft>
-                <a:spcPts val="1000"/>
+                <a:spcPts val="800"/>
               </a:spcAft>
             </a:pPr>
             <a:r>
@@ -4947,13 +4999,13 @@
                 </a:solidFill>
                 <a:latin typeface="Calibri"/>
               </a:rPr>
-              <a:t>  •  Imputacion comparativa: mediana vs IterativeImputer (BayesianRidge) -&gt; se eligio la segunda por preservar la varianza</a:t>
+              <a:t>  •  Detecté 40 outliers con IQR, los traté con capping para no perder filas</a:t>
             </a:r>
           </a:p>
           <a:p>
             <a:pPr algn="l">
               <a:spcAft>
-                <a:spcPts val="1000"/>
+                <a:spcPts val="800"/>
               </a:spcAft>
             </a:pPr>
             <a:r>
@@ -4963,7 +5015,7 @@
                 </a:solidFill>
                 <a:latin typeface="Calibri"/>
               </a:rPr>
-              <a:t>  •  Dataset final listo para modelado: 303 filas x 13 features + target</a:t>
+              <a:t>  •  Comparé imputación por mediana vs por regresión bayesiana → me quedé con la segunda</a:t>
             </a:r>
           </a:p>
         </p:txBody>
@@ -4985,17 +5037,18 @@
           <a:noFill/>
         </p:spPr>
         <p:txBody>
-          <a:bodyPr wrap="none">
+          <a:bodyPr wrap="square">
             <a:spAutoFit/>
           </a:bodyPr>
           <a:lstStyle/>
           <a:p>
             <a:pPr algn="r"/>
             <a:r>
-              <a:rPr sz="1100">
+              <a:rPr b="0" i="0" sz="1100">
                 <a:solidFill>
                   <a:srgbClr val="2E86AB"/>
                 </a:solidFill>
+                <a:latin typeface="Calibri"/>
               </a:rPr>
               <a:t>4 / 12</a:t>
             </a:r>
@@ -5044,13 +5097,13 @@
           <a:p>
             <a:pPr algn="l"/>
             <a:r>
-              <a:rPr b="1" sz="3200">
-                <a:solidFill>
-                  <a:srgbClr val="222222"/>
-                </a:solidFill>
-                <a:latin typeface="Calibri"/>
-              </a:rPr>
-              <a:t>VI. PCA - Varianza explicada y proyeccion 2D</a:t>
+              <a:rPr b="1" i="0" sz="3200">
+                <a:solidFill>
+                  <a:srgbClr val="2E86AB"/>
+                </a:solidFill>
+                <a:latin typeface="Calibri"/>
+              </a:rPr>
+              <a:t>PCA: ¿cuántos componentes necesito?</a:t>
             </a:r>
           </a:p>
         </p:txBody>
@@ -5064,7 +5117,7 @@
         <p:spPr>
           <a:xfrm>
             <a:off x="548640" y="1005840"/>
-            <a:ext cx="11091672" cy="777240"/>
+            <a:ext cx="11091672" cy="457200"/>
           </a:xfrm>
           <a:prstGeom prst="rect">
             <a:avLst/>
@@ -5079,13 +5132,13 @@
           <a:p>
             <a:pPr algn="l"/>
             <a:r>
-              <a:rPr b="0" sz="1800">
-                <a:solidFill>
-                  <a:srgbClr val="2E86AB"/>
-                </a:solidFill>
-                <a:latin typeface="Calibri"/>
-              </a:rPr>
-              <a:t>8 componentes preservan el 80% de la varianza original</a:t>
+              <a:rPr b="0" i="0" sz="1800">
+                <a:solidFill>
+                  <a:srgbClr val="A23B72"/>
+                </a:solidFill>
+                <a:latin typeface="Calibri"/>
+              </a:rPr>
+              <a:t>Con 8 componentes ya tengo el 80% de la varianza</a:t>
             </a:r>
           </a:p>
         </p:txBody>
@@ -5106,8 +5159,8 @@
         </p:blipFill>
         <p:spPr>
           <a:xfrm>
-            <a:off x="731520" y="1463040"/>
-            <a:ext cx="10698480" cy="3717362"/>
+            <a:off x="731520" y="1554480"/>
+            <a:ext cx="10698480" cy="3730100"/>
           </a:xfrm>
           <a:prstGeom prst="rect">
             <a:avLst/>
@@ -5131,17 +5184,18 @@
           <a:noFill/>
         </p:spPr>
         <p:txBody>
-          <a:bodyPr wrap="none">
+          <a:bodyPr wrap="square">
             <a:spAutoFit/>
           </a:bodyPr>
           <a:lstStyle/>
           <a:p>
             <a:pPr algn="r"/>
             <a:r>
-              <a:rPr sz="1100">
+              <a:rPr b="0" i="0" sz="1100">
                 <a:solidFill>
                   <a:srgbClr val="2E86AB"/>
                 </a:solidFill>
+                <a:latin typeface="Calibri"/>
               </a:rPr>
               <a:t>5 / 12</a:t>
             </a:r>
@@ -5190,13 +5244,13 @@
           <a:p>
             <a:pPr algn="l"/>
             <a:r>
-              <a:rPr b="1" sz="3200">
-                <a:solidFill>
-                  <a:srgbClr val="222222"/>
-                </a:solidFill>
-                <a:latin typeface="Calibri"/>
-              </a:rPr>
-              <a:t>VI. PCA - Interpretacion de componentes</a:t>
+              <a:rPr b="1" i="0" sz="3200">
+                <a:solidFill>
+                  <a:srgbClr val="2E86AB"/>
+                </a:solidFill>
+                <a:latin typeface="Calibri"/>
+              </a:rPr>
+              <a:t>¿Qué significa cada componente?</a:t>
             </a:r>
           </a:p>
         </p:txBody>
@@ -5210,7 +5264,7 @@
         <p:spPr>
           <a:xfrm>
             <a:off x="548640" y="1005840"/>
-            <a:ext cx="11091672" cy="777240"/>
+            <a:ext cx="11091672" cy="457200"/>
           </a:xfrm>
           <a:prstGeom prst="rect">
             <a:avLst/>
@@ -5225,13 +5279,13 @@
           <a:p>
             <a:pPr algn="l"/>
             <a:r>
-              <a:rPr b="0" sz="1800">
-                <a:solidFill>
-                  <a:srgbClr val="2E86AB"/>
-                </a:solidFill>
-                <a:latin typeface="Calibri"/>
-              </a:rPr>
-              <a:t>PC1 = severidad cardiaca; PC2 = eje demografico-metabolico</a:t>
+              <a:rPr b="0" i="0" sz="1800">
+                <a:solidFill>
+                  <a:srgbClr val="A23B72"/>
+                </a:solidFill>
+                <a:latin typeface="Calibri"/>
+              </a:rPr>
+              <a:t>Mirando las cargas le encontré sentido a los 2 primeros</a:t>
             </a:r>
           </a:p>
         </p:txBody>
@@ -5252,8 +5306,8 @@
         </p:blipFill>
         <p:spPr>
           <a:xfrm>
-            <a:off x="548640" y="1463040"/>
-            <a:ext cx="6675120" cy="4980265"/>
+            <a:off x="457200" y="1554480"/>
+            <a:ext cx="6400800" cy="4780597"/>
           </a:xfrm>
           <a:prstGeom prst="rect">
             <a:avLst/>
@@ -5268,8 +5322,8 @@
         </p:nvSpPr>
         <p:spPr>
           <a:xfrm>
-            <a:off x="7498079" y="1828800"/>
-            <a:ext cx="4297680" cy="4114800"/>
+            <a:off x="7315200" y="1828800"/>
+            <a:ext cx="4572000" cy="457200"/>
           </a:xfrm>
           <a:prstGeom prst="rect">
             <a:avLst/>
@@ -5282,93 +5336,15 @@
           </a:bodyPr>
           <a:lstStyle/>
           <a:p>
-            <a:pPr>
-              <a:spcAft>
-                <a:spcPts val="200"/>
-              </a:spcAft>
-            </a:pPr>
-            <a:r>
-              <a:rPr b="1" sz="1600">
+            <a:pPr algn="l"/>
+            <a:r>
+              <a:rPr b="1" i="0" sz="1700">
                 <a:solidFill>
                   <a:srgbClr val="A23B72"/>
                 </a:solidFill>
-              </a:rPr>
-              <a:t>PC1: oldpeak, exang, thal, ca</a:t>
-            </a:r>
-          </a:p>
-          <a:p>
-            <a:pPr>
-              <a:spcAft>
-                <a:spcPts val="1200"/>
-              </a:spcAft>
-            </a:pPr>
-            <a:r>
-              <a:rPr sz="1400">
-                <a:solidFill>
-                  <a:srgbClr val="222222"/>
-                </a:solidFill>
-              </a:rPr>
-              <a:t>Variables clinicas y de imagen asociadas a severidad coronaria</a:t>
-            </a:r>
-          </a:p>
-          <a:p>
-            <a:pPr>
-              <a:spcAft>
-                <a:spcPts val="200"/>
-              </a:spcAft>
-            </a:pPr>
-            <a:r>
-              <a:rPr b="1" sz="1600">
-                <a:solidFill>
-                  <a:srgbClr val="A23B72"/>
-                </a:solidFill>
-              </a:rPr>
-              <a:t>PC2: age, sex, chol</a:t>
-            </a:r>
-          </a:p>
-          <a:p>
-            <a:pPr>
-              <a:spcAft>
-                <a:spcPts val="1200"/>
-              </a:spcAft>
-            </a:pPr>
-            <a:r>
-              <a:rPr sz="1400">
-                <a:solidFill>
-                  <a:srgbClr val="222222"/>
-                </a:solidFill>
-              </a:rPr>
-              <a:t>Eje demografico-metabolico (perfil del paciente)</a:t>
-            </a:r>
-          </a:p>
-          <a:p>
-            <a:pPr>
-              <a:spcAft>
-                <a:spcPts val="200"/>
-              </a:spcAft>
-            </a:pPr>
-            <a:r>
-              <a:rPr b="1" sz="1600">
-                <a:solidFill>
-                  <a:srgbClr val="A23B72"/>
-                </a:solidFill>
-              </a:rPr>
-              <a:t>Reduccion 13 -&gt; 8 (38%)</a:t>
-            </a:r>
-          </a:p>
-          <a:p>
-            <a:pPr>
-              <a:spcAft>
-                <a:spcPts val="1200"/>
-              </a:spcAft>
-            </a:pPr>
-            <a:r>
-              <a:rPr sz="1400">
-                <a:solidFill>
-                  <a:srgbClr val="222222"/>
-                </a:solidFill>
-              </a:rPr>
-              <a:t>Equilibrio entre simplicidad e informacion preservada</a:t>
+                <a:latin typeface="Calibri"/>
+              </a:rPr>
+              <a:t>PC1 – Severidad cardíaca</a:t>
             </a:r>
           </a:p>
         </p:txBody>
@@ -5381,6 +5357,148 @@
         </p:nvSpPr>
         <p:spPr>
           <a:xfrm>
+            <a:off x="7315200" y="2331720"/>
+            <a:ext cx="4572000" cy="914400"/>
+          </a:xfrm>
+          <a:prstGeom prst="rect">
+            <a:avLst/>
+          </a:prstGeom>
+          <a:noFill/>
+        </p:spPr>
+        <p:txBody>
+          <a:bodyPr wrap="square">
+            <a:spAutoFit/>
+          </a:bodyPr>
+          <a:lstStyle/>
+          <a:p>
+            <a:pPr algn="l"/>
+            <a:r>
+              <a:rPr b="0" i="0" sz="1400">
+                <a:solidFill>
+                  <a:srgbClr val="222222"/>
+                </a:solidFill>
+                <a:latin typeface="Calibri"/>
+              </a:rPr>
+              <a:t>Carga sobre oldpeak, exang, thal y ca.
+Son todos hallazgos clínicos.</a:t>
+            </a:r>
+          </a:p>
+        </p:txBody>
+      </p:sp>
+      <p:sp>
+        <p:nvSpPr>
+          <p:cNvPr id="7" name="TextBox 6"/>
+          <p:cNvSpPr txBox="1"/>
+          <p:nvPr/>
+        </p:nvSpPr>
+        <p:spPr>
+          <a:xfrm>
+            <a:off x="7315200" y="3520440"/>
+            <a:ext cx="4572000" cy="457200"/>
+          </a:xfrm>
+          <a:prstGeom prst="rect">
+            <a:avLst/>
+          </a:prstGeom>
+          <a:noFill/>
+        </p:spPr>
+        <p:txBody>
+          <a:bodyPr wrap="square">
+            <a:spAutoFit/>
+          </a:bodyPr>
+          <a:lstStyle/>
+          <a:p>
+            <a:pPr algn="l"/>
+            <a:r>
+              <a:rPr b="1" i="0" sz="1700">
+                <a:solidFill>
+                  <a:srgbClr val="A23B72"/>
+                </a:solidFill>
+                <a:latin typeface="Calibri"/>
+              </a:rPr>
+              <a:t>PC2 – Perfil del paciente</a:t>
+            </a:r>
+          </a:p>
+        </p:txBody>
+      </p:sp>
+      <p:sp>
+        <p:nvSpPr>
+          <p:cNvPr id="8" name="TextBox 7"/>
+          <p:cNvSpPr txBox="1"/>
+          <p:nvPr/>
+        </p:nvSpPr>
+        <p:spPr>
+          <a:xfrm>
+            <a:off x="7315200" y="4023360"/>
+            <a:ext cx="4572000" cy="914400"/>
+          </a:xfrm>
+          <a:prstGeom prst="rect">
+            <a:avLst/>
+          </a:prstGeom>
+          <a:noFill/>
+        </p:spPr>
+        <p:txBody>
+          <a:bodyPr wrap="square">
+            <a:spAutoFit/>
+          </a:bodyPr>
+          <a:lstStyle/>
+          <a:p>
+            <a:pPr algn="l"/>
+            <a:r>
+              <a:rPr b="0" i="0" sz="1400">
+                <a:solidFill>
+                  <a:srgbClr val="222222"/>
+                </a:solidFill>
+                <a:latin typeface="Calibri"/>
+              </a:rPr>
+              <a:t>Carga sobre sex, chol y age.
+Más un eje demográfico.</a:t>
+            </a:r>
+          </a:p>
+        </p:txBody>
+      </p:sp>
+      <p:sp>
+        <p:nvSpPr>
+          <p:cNvPr id="9" name="TextBox 8"/>
+          <p:cNvSpPr txBox="1"/>
+          <p:nvPr/>
+        </p:nvSpPr>
+        <p:spPr>
+          <a:xfrm>
+            <a:off x="7315200" y="5212080"/>
+            <a:ext cx="4572000" cy="457200"/>
+          </a:xfrm>
+          <a:prstGeom prst="rect">
+            <a:avLst/>
+          </a:prstGeom>
+          <a:noFill/>
+        </p:spPr>
+        <p:txBody>
+          <a:bodyPr wrap="square">
+            <a:spAutoFit/>
+          </a:bodyPr>
+          <a:lstStyle/>
+          <a:p>
+            <a:pPr algn="l"/>
+            <a:r>
+              <a:rPr b="1" i="0" sz="1400">
+                <a:solidFill>
+                  <a:srgbClr val="2E86AB"/>
+                </a:solidFill>
+                <a:latin typeface="Calibri"/>
+              </a:rPr>
+              <a:t>Reducción: de 13 a 8 variables (38% menos)</a:t>
+            </a:r>
+          </a:p>
+        </p:txBody>
+      </p:sp>
+      <p:sp>
+        <p:nvSpPr>
+          <p:cNvPr id="10" name="TextBox 9"/>
+          <p:cNvSpPr txBox="1"/>
+          <p:nvPr/>
+        </p:nvSpPr>
+        <p:spPr>
+          <a:xfrm>
             <a:off x="10515600" y="6446520"/>
             <a:ext cx="1554480" cy="320040"/>
           </a:xfrm>
@@ -5390,17 +5508,18 @@
           <a:noFill/>
         </p:spPr>
         <p:txBody>
-          <a:bodyPr wrap="none">
+          <a:bodyPr wrap="square">
             <a:spAutoFit/>
           </a:bodyPr>
           <a:lstStyle/>
           <a:p>
             <a:pPr algn="r"/>
             <a:r>
-              <a:rPr sz="1100">
+              <a:rPr b="0" i="0" sz="1100">
                 <a:solidFill>
                   <a:srgbClr val="2E86AB"/>
                 </a:solidFill>
+                <a:latin typeface="Calibri"/>
               </a:rPr>
               <a:t>6 / 12</a:t>
             </a:r>
@@ -5449,13 +5568,13 @@
           <a:p>
             <a:pPr algn="l"/>
             <a:r>
-              <a:rPr b="1" sz="3200">
-                <a:solidFill>
-                  <a:srgbClr val="222222"/>
-                </a:solidFill>
-                <a:latin typeface="Calibri"/>
-              </a:rPr>
-              <a:t>VII. Seleccion de caracteristicas (filtro Pearson)</a:t>
+              <a:rPr b="1" i="0" sz="3200">
+                <a:solidFill>
+                  <a:srgbClr val="2E86AB"/>
+                </a:solidFill>
+                <a:latin typeface="Calibri"/>
+              </a:rPr>
+              <a:t>Selección de variables por correlación</a:t>
             </a:r>
           </a:p>
         </p:txBody>
@@ -5469,7 +5588,7 @@
         <p:spPr>
           <a:xfrm>
             <a:off x="548640" y="1005840"/>
-            <a:ext cx="11091672" cy="777240"/>
+            <a:ext cx="11091672" cy="457200"/>
           </a:xfrm>
           <a:prstGeom prst="rect">
             <a:avLst/>
@@ -5484,13 +5603,13 @@
           <a:p>
             <a:pPr algn="l"/>
             <a:r>
-              <a:rPr b="0" sz="1800">
-                <a:solidFill>
-                  <a:srgbClr val="2E86AB"/>
-                </a:solidFill>
-                <a:latin typeface="Calibri"/>
-              </a:rPr>
-              <a:t>Top 5: thal, ca, exang, oldpeak, thalach</a:t>
+              <a:rPr b="0" i="0" sz="1800">
+                <a:solidFill>
+                  <a:srgbClr val="A23B72"/>
+                </a:solidFill>
+                <a:latin typeface="Calibri"/>
+              </a:rPr>
+              <a:t>Las 5 variables más correlacionadas con el target</a:t>
             </a:r>
           </a:p>
         </p:txBody>
@@ -5511,8 +5630,8 @@
         </p:blipFill>
         <p:spPr>
           <a:xfrm>
-            <a:off x="548640" y="1463040"/>
-            <a:ext cx="6949440" cy="3414026"/>
+            <a:off x="457200" y="1554480"/>
+            <a:ext cx="6858000" cy="3369192"/>
           </a:xfrm>
           <a:prstGeom prst="rect">
             <a:avLst/>
@@ -5528,7 +5647,7 @@
         <p:spPr>
           <a:xfrm>
             <a:off x="7772400" y="1828800"/>
-            <a:ext cx="4023360" cy="4114800"/>
+            <a:ext cx="4114800" cy="457200"/>
           </a:xfrm>
           <a:prstGeom prst="rect">
             <a:avLst/>
@@ -5541,133 +5660,15 @@
           </a:bodyPr>
           <a:lstStyle/>
           <a:p>
-            <a:pPr>
-              <a:spcAft>
-                <a:spcPts val="800"/>
-              </a:spcAft>
-            </a:pPr>
-            <a:r>
-              <a:rPr b="1" sz="1800">
+            <a:pPr algn="l"/>
+            <a:r>
+              <a:rPr b="1" i="0" sz="2000">
                 <a:solidFill>
                   <a:srgbClr val="A23B72"/>
                 </a:solidFill>
-              </a:rPr>
-              <a:t>Top 5 features</a:t>
-            </a:r>
-          </a:p>
-          <a:p>
-            <a:pPr>
-              <a:spcAft>
-                <a:spcPts val="600"/>
-              </a:spcAft>
-            </a:pPr>
-            <a:r>
-              <a:rPr b="1" sz="1500">
-                <a:solidFill>
-                  <a:srgbClr val="2E86AB"/>
-                </a:solidFill>
-              </a:rPr>
-              <a:t>  thal (0.5221)  </a:t>
-            </a:r>
-            <a:r>
-              <a:rPr sz="1400">
-                <a:solidFill>
-                  <a:srgbClr val="222222"/>
-                </a:solidFill>
-              </a:rPr>
-              <a:t>Talasemia</a:t>
-            </a:r>
-          </a:p>
-          <a:p>
-            <a:pPr>
-              <a:spcAft>
-                <a:spcPts val="600"/>
-              </a:spcAft>
-            </a:pPr>
-            <a:r>
-              <a:rPr b="1" sz="1500">
-                <a:solidFill>
-                  <a:srgbClr val="2E86AB"/>
-                </a:solidFill>
-              </a:rPr>
-              <a:t>  ca (0.4702)  </a:t>
-            </a:r>
-            <a:r>
-              <a:rPr sz="1400">
-                <a:solidFill>
-                  <a:srgbClr val="222222"/>
-                </a:solidFill>
-              </a:rPr>
-              <a:t>Vasos fluoroscopia</a:t>
-            </a:r>
-          </a:p>
-          <a:p>
-            <a:pPr>
-              <a:spcAft>
-                <a:spcPts val="600"/>
-              </a:spcAft>
-            </a:pPr>
-            <a:r>
-              <a:rPr b="1" sz="1500">
-                <a:solidFill>
-                  <a:srgbClr val="2E86AB"/>
-                </a:solidFill>
-              </a:rPr>
-              <a:t>  exang (0.4319)  </a:t>
-            </a:r>
-            <a:r>
-              <a:rPr sz="1400">
-                <a:solidFill>
-                  <a:srgbClr val="222222"/>
-                </a:solidFill>
-              </a:rPr>
-              <a:t>Angina ejercicio</a:t>
-            </a:r>
-          </a:p>
-          <a:p>
-            <a:pPr>
-              <a:spcAft>
-                <a:spcPts val="600"/>
-              </a:spcAft>
-            </a:pPr>
-            <a:r>
-              <a:rPr b="1" sz="1500">
-                <a:solidFill>
-                  <a:srgbClr val="2E86AB"/>
-                </a:solidFill>
-              </a:rPr>
-              <a:t>  oldpeak (0.4303)  </a:t>
-            </a:r>
-            <a:r>
-              <a:rPr sz="1400">
-                <a:solidFill>
-                  <a:srgbClr val="222222"/>
-                </a:solidFill>
-              </a:rPr>
-              <a:t>Depresion ST</a:t>
-            </a:r>
-          </a:p>
-          <a:p>
-            <a:pPr>
-              <a:spcAft>
-                <a:spcPts val="600"/>
-              </a:spcAft>
-            </a:pPr>
-            <a:r>
-              <a:rPr b="1" sz="1500">
-                <a:solidFill>
-                  <a:srgbClr val="2E86AB"/>
-                </a:solidFill>
-              </a:rPr>
-              <a:t>  thalach (0.4176)  </a:t>
-            </a:r>
-            <a:r>
-              <a:rPr sz="1400">
-                <a:solidFill>
-                  <a:srgbClr val="222222"/>
-                </a:solidFill>
-              </a:rPr>
-              <a:t>Frecuencia max.</a:t>
+                <a:latin typeface="Calibri"/>
+              </a:rPr>
+              <a:t>Top 5</a:t>
             </a:r>
           </a:p>
         </p:txBody>
@@ -5680,6 +5681,356 @@
         </p:nvSpPr>
         <p:spPr>
           <a:xfrm>
+            <a:off x="7772400" y="2377440"/>
+            <a:ext cx="2103120" cy="365760"/>
+          </a:xfrm>
+          <a:prstGeom prst="rect">
+            <a:avLst/>
+          </a:prstGeom>
+          <a:noFill/>
+        </p:spPr>
+        <p:txBody>
+          <a:bodyPr wrap="square">
+            <a:spAutoFit/>
+          </a:bodyPr>
+          <a:lstStyle/>
+          <a:p>
+            <a:pPr algn="l"/>
+            <a:r>
+              <a:rPr b="1" i="0" sz="1500">
+                <a:solidFill>
+                  <a:srgbClr val="2E86AB"/>
+                </a:solidFill>
+                <a:latin typeface="Calibri"/>
+              </a:rPr>
+              <a:t>thal  (0.522)</a:t>
+            </a:r>
+          </a:p>
+        </p:txBody>
+      </p:sp>
+      <p:sp>
+        <p:nvSpPr>
+          <p:cNvPr id="7" name="TextBox 6"/>
+          <p:cNvSpPr txBox="1"/>
+          <p:nvPr/>
+        </p:nvSpPr>
+        <p:spPr>
+          <a:xfrm>
+            <a:off x="9784080" y="2377440"/>
+            <a:ext cx="2286000" cy="365760"/>
+          </a:xfrm>
+          <a:prstGeom prst="rect">
+            <a:avLst/>
+          </a:prstGeom>
+          <a:noFill/>
+        </p:spPr>
+        <p:txBody>
+          <a:bodyPr wrap="square">
+            <a:spAutoFit/>
+          </a:bodyPr>
+          <a:lstStyle/>
+          <a:p>
+            <a:pPr algn="l"/>
+            <a:r>
+              <a:rPr b="0" i="0" sz="1400">
+                <a:solidFill>
+                  <a:srgbClr val="222222"/>
+                </a:solidFill>
+                <a:latin typeface="Calibri"/>
+              </a:rPr>
+              <a:t>Talasemia</a:t>
+            </a:r>
+          </a:p>
+        </p:txBody>
+      </p:sp>
+      <p:sp>
+        <p:nvSpPr>
+          <p:cNvPr id="8" name="TextBox 7"/>
+          <p:cNvSpPr txBox="1"/>
+          <p:nvPr/>
+        </p:nvSpPr>
+        <p:spPr>
+          <a:xfrm>
+            <a:off x="7772400" y="2880360"/>
+            <a:ext cx="2103120" cy="365760"/>
+          </a:xfrm>
+          <a:prstGeom prst="rect">
+            <a:avLst/>
+          </a:prstGeom>
+          <a:noFill/>
+        </p:spPr>
+        <p:txBody>
+          <a:bodyPr wrap="square">
+            <a:spAutoFit/>
+          </a:bodyPr>
+          <a:lstStyle/>
+          <a:p>
+            <a:pPr algn="l"/>
+            <a:r>
+              <a:rPr b="1" i="0" sz="1500">
+                <a:solidFill>
+                  <a:srgbClr val="2E86AB"/>
+                </a:solidFill>
+                <a:latin typeface="Calibri"/>
+              </a:rPr>
+              <a:t>ca  (0.470)</a:t>
+            </a:r>
+          </a:p>
+        </p:txBody>
+      </p:sp>
+      <p:sp>
+        <p:nvSpPr>
+          <p:cNvPr id="9" name="TextBox 8"/>
+          <p:cNvSpPr txBox="1"/>
+          <p:nvPr/>
+        </p:nvSpPr>
+        <p:spPr>
+          <a:xfrm>
+            <a:off x="9784080" y="2880360"/>
+            <a:ext cx="2286000" cy="365760"/>
+          </a:xfrm>
+          <a:prstGeom prst="rect">
+            <a:avLst/>
+          </a:prstGeom>
+          <a:noFill/>
+        </p:spPr>
+        <p:txBody>
+          <a:bodyPr wrap="square">
+            <a:spAutoFit/>
+          </a:bodyPr>
+          <a:lstStyle/>
+          <a:p>
+            <a:pPr algn="l"/>
+            <a:r>
+              <a:rPr b="0" i="0" sz="1400">
+                <a:solidFill>
+                  <a:srgbClr val="222222"/>
+                </a:solidFill>
+                <a:latin typeface="Calibri"/>
+              </a:rPr>
+              <a:t>Vasos fluoroscopia</a:t>
+            </a:r>
+          </a:p>
+        </p:txBody>
+      </p:sp>
+      <p:sp>
+        <p:nvSpPr>
+          <p:cNvPr id="10" name="TextBox 9"/>
+          <p:cNvSpPr txBox="1"/>
+          <p:nvPr/>
+        </p:nvSpPr>
+        <p:spPr>
+          <a:xfrm>
+            <a:off x="7772400" y="3383280"/>
+            <a:ext cx="2103120" cy="365760"/>
+          </a:xfrm>
+          <a:prstGeom prst="rect">
+            <a:avLst/>
+          </a:prstGeom>
+          <a:noFill/>
+        </p:spPr>
+        <p:txBody>
+          <a:bodyPr wrap="square">
+            <a:spAutoFit/>
+          </a:bodyPr>
+          <a:lstStyle/>
+          <a:p>
+            <a:pPr algn="l"/>
+            <a:r>
+              <a:rPr b="1" i="0" sz="1500">
+                <a:solidFill>
+                  <a:srgbClr val="2E86AB"/>
+                </a:solidFill>
+                <a:latin typeface="Calibri"/>
+              </a:rPr>
+              <a:t>exang  (0.432)</a:t>
+            </a:r>
+          </a:p>
+        </p:txBody>
+      </p:sp>
+      <p:sp>
+        <p:nvSpPr>
+          <p:cNvPr id="11" name="TextBox 10"/>
+          <p:cNvSpPr txBox="1"/>
+          <p:nvPr/>
+        </p:nvSpPr>
+        <p:spPr>
+          <a:xfrm>
+            <a:off x="9784080" y="3383280"/>
+            <a:ext cx="2286000" cy="365760"/>
+          </a:xfrm>
+          <a:prstGeom prst="rect">
+            <a:avLst/>
+          </a:prstGeom>
+          <a:noFill/>
+        </p:spPr>
+        <p:txBody>
+          <a:bodyPr wrap="square">
+            <a:spAutoFit/>
+          </a:bodyPr>
+          <a:lstStyle/>
+          <a:p>
+            <a:pPr algn="l"/>
+            <a:r>
+              <a:rPr b="0" i="0" sz="1400">
+                <a:solidFill>
+                  <a:srgbClr val="222222"/>
+                </a:solidFill>
+                <a:latin typeface="Calibri"/>
+              </a:rPr>
+              <a:t>Angina con ejercicio</a:t>
+            </a:r>
+          </a:p>
+        </p:txBody>
+      </p:sp>
+      <p:sp>
+        <p:nvSpPr>
+          <p:cNvPr id="12" name="TextBox 11"/>
+          <p:cNvSpPr txBox="1"/>
+          <p:nvPr/>
+        </p:nvSpPr>
+        <p:spPr>
+          <a:xfrm>
+            <a:off x="7772400" y="3886200"/>
+            <a:ext cx="2103120" cy="365760"/>
+          </a:xfrm>
+          <a:prstGeom prst="rect">
+            <a:avLst/>
+          </a:prstGeom>
+          <a:noFill/>
+        </p:spPr>
+        <p:txBody>
+          <a:bodyPr wrap="square">
+            <a:spAutoFit/>
+          </a:bodyPr>
+          <a:lstStyle/>
+          <a:p>
+            <a:pPr algn="l"/>
+            <a:r>
+              <a:rPr b="1" i="0" sz="1500">
+                <a:solidFill>
+                  <a:srgbClr val="2E86AB"/>
+                </a:solidFill>
+                <a:latin typeface="Calibri"/>
+              </a:rPr>
+              <a:t>oldpeak  (0.430)</a:t>
+            </a:r>
+          </a:p>
+        </p:txBody>
+      </p:sp>
+      <p:sp>
+        <p:nvSpPr>
+          <p:cNvPr id="13" name="TextBox 12"/>
+          <p:cNvSpPr txBox="1"/>
+          <p:nvPr/>
+        </p:nvSpPr>
+        <p:spPr>
+          <a:xfrm>
+            <a:off x="9784080" y="3886200"/>
+            <a:ext cx="2286000" cy="365760"/>
+          </a:xfrm>
+          <a:prstGeom prst="rect">
+            <a:avLst/>
+          </a:prstGeom>
+          <a:noFill/>
+        </p:spPr>
+        <p:txBody>
+          <a:bodyPr wrap="square">
+            <a:spAutoFit/>
+          </a:bodyPr>
+          <a:lstStyle/>
+          <a:p>
+            <a:pPr algn="l"/>
+            <a:r>
+              <a:rPr b="0" i="0" sz="1400">
+                <a:solidFill>
+                  <a:srgbClr val="222222"/>
+                </a:solidFill>
+                <a:latin typeface="Calibri"/>
+              </a:rPr>
+              <a:t>Depresión ST</a:t>
+            </a:r>
+          </a:p>
+        </p:txBody>
+      </p:sp>
+      <p:sp>
+        <p:nvSpPr>
+          <p:cNvPr id="14" name="TextBox 13"/>
+          <p:cNvSpPr txBox="1"/>
+          <p:nvPr/>
+        </p:nvSpPr>
+        <p:spPr>
+          <a:xfrm>
+            <a:off x="7772400" y="4389120"/>
+            <a:ext cx="2103120" cy="365760"/>
+          </a:xfrm>
+          <a:prstGeom prst="rect">
+            <a:avLst/>
+          </a:prstGeom>
+          <a:noFill/>
+        </p:spPr>
+        <p:txBody>
+          <a:bodyPr wrap="square">
+            <a:spAutoFit/>
+          </a:bodyPr>
+          <a:lstStyle/>
+          <a:p>
+            <a:pPr algn="l"/>
+            <a:r>
+              <a:rPr b="1" i="0" sz="1500">
+                <a:solidFill>
+                  <a:srgbClr val="2E86AB"/>
+                </a:solidFill>
+                <a:latin typeface="Calibri"/>
+              </a:rPr>
+              <a:t>thalach  (0.418)</a:t>
+            </a:r>
+          </a:p>
+        </p:txBody>
+      </p:sp>
+      <p:sp>
+        <p:nvSpPr>
+          <p:cNvPr id="15" name="TextBox 14"/>
+          <p:cNvSpPr txBox="1"/>
+          <p:nvPr/>
+        </p:nvSpPr>
+        <p:spPr>
+          <a:xfrm>
+            <a:off x="9784080" y="4389120"/>
+            <a:ext cx="2286000" cy="365760"/>
+          </a:xfrm>
+          <a:prstGeom prst="rect">
+            <a:avLst/>
+          </a:prstGeom>
+          <a:noFill/>
+        </p:spPr>
+        <p:txBody>
+          <a:bodyPr wrap="square">
+            <a:spAutoFit/>
+          </a:bodyPr>
+          <a:lstStyle/>
+          <a:p>
+            <a:pPr algn="l"/>
+            <a:r>
+              <a:rPr b="0" i="0" sz="1400">
+                <a:solidFill>
+                  <a:srgbClr val="222222"/>
+                </a:solidFill>
+                <a:latin typeface="Calibri"/>
+              </a:rPr>
+              <a:t>Frec. máx.</a:t>
+            </a:r>
+          </a:p>
+        </p:txBody>
+      </p:sp>
+      <p:sp>
+        <p:nvSpPr>
+          <p:cNvPr id="16" name="TextBox 15"/>
+          <p:cNvSpPr txBox="1"/>
+          <p:nvPr/>
+        </p:nvSpPr>
+        <p:spPr>
+          <a:xfrm>
             <a:off x="10515600" y="6446520"/>
             <a:ext cx="1554480" cy="320040"/>
           </a:xfrm>
@@ -5689,17 +6040,18 @@
           <a:noFill/>
         </p:spPr>
         <p:txBody>
-          <a:bodyPr wrap="none">
+          <a:bodyPr wrap="square">
             <a:spAutoFit/>
           </a:bodyPr>
           <a:lstStyle/>
           <a:p>
             <a:pPr algn="r"/>
             <a:r>
-              <a:rPr sz="1100">
+              <a:rPr b="0" i="0" sz="1100">
                 <a:solidFill>
                   <a:srgbClr val="2E86AB"/>
                 </a:solidFill>
+                <a:latin typeface="Calibri"/>
               </a:rPr>
               <a:t>7 / 12</a:t>
             </a:r>
@@ -5748,13 +6100,13 @@
           <a:p>
             <a:pPr algn="l"/>
             <a:r>
-              <a:rPr b="1" sz="3200">
-                <a:solidFill>
-                  <a:srgbClr val="222222"/>
-                </a:solidFill>
-                <a:latin typeface="Calibri"/>
-              </a:rPr>
-              <a:t>VIII. Modelamiento - Setup experimental</a:t>
+              <a:rPr b="1" i="0" sz="3200">
+                <a:solidFill>
+                  <a:srgbClr val="2E86AB"/>
+                </a:solidFill>
+                <a:latin typeface="Calibri"/>
+              </a:rPr>
+              <a:t>Los dos modelos que comparé</a:t>
             </a:r>
           </a:p>
         </p:txBody>
@@ -5768,7 +6120,7 @@
         <p:spPr>
           <a:xfrm>
             <a:off x="548640" y="1005840"/>
-            <a:ext cx="11091672" cy="777240"/>
+            <a:ext cx="11091672" cy="457200"/>
           </a:xfrm>
           <a:prstGeom prst="rect">
             <a:avLst/>
@@ -5783,13 +6135,13 @@
           <a:p>
             <a:pPr algn="l"/>
             <a:r>
-              <a:rPr b="0" sz="1800">
-                <a:solidFill>
-                  <a:srgbClr val="2E86AB"/>
-                </a:solidFill>
-                <a:latin typeface="Calibri"/>
-              </a:rPr>
-              <a:t>Comparacion entre dos modelos supervisados vistos en clase</a:t>
+              <a:rPr b="0" i="0" sz="1800">
+                <a:solidFill>
+                  <a:srgbClr val="A23B72"/>
+                </a:solidFill>
+                <a:latin typeface="Calibri"/>
+              </a:rPr>
+              <a:t>Escogí los dos primeros ejemplos que pone el profesor en la rúbrica</a:t>
             </a:r>
           </a:p>
         </p:txBody>
@@ -5802,8 +6154,8 @@
         </p:nvSpPr>
         <p:spPr>
           <a:xfrm>
-            <a:off x="640080" y="1554480"/>
-            <a:ext cx="10972800" cy="4754880"/>
+            <a:off x="640080" y="1691640"/>
+            <a:ext cx="10972800" cy="4572000"/>
           </a:xfrm>
           <a:prstGeom prst="rect">
             <a:avLst/>
@@ -5818,7 +6170,7 @@
           <a:p>
             <a:pPr algn="l">
               <a:spcAft>
-                <a:spcPts val="1000"/>
+                <a:spcPts val="800"/>
               </a:spcAft>
             </a:pPr>
             <a:r>
@@ -5828,13 +6180,13 @@
                 </a:solidFill>
                 <a:latin typeface="Calibri"/>
               </a:rPr>
-              <a:t>  •  Particion estratificada 80/20: 242 train | 61 test (random_state = 42)</a:t>
+              <a:t>  •  División 80/20 estratificada (random_state = 42)</a:t>
             </a:r>
           </a:p>
           <a:p>
             <a:pPr algn="l">
               <a:spcAft>
-                <a:spcPts val="1000"/>
+                <a:spcPts val="800"/>
               </a:spcAft>
             </a:pPr>
             <a:r>
@@ -5844,13 +6196,13 @@
                 </a:solidFill>
                 <a:latin typeface="Calibri"/>
               </a:rPr>
-              <a:t>  •  Modelo 1 - Regresion Logistica: max_iter=2000, features estandarizadas</a:t>
+              <a:t>  •  Modelo 1: Regresión Logística (lineal, max_iter = 2000, features estandarizadas)</a:t>
             </a:r>
           </a:p>
           <a:p>
             <a:pPr algn="l">
               <a:spcAft>
-                <a:spcPts val="1000"/>
+                <a:spcPts val="800"/>
               </a:spcAft>
             </a:pPr>
             <a:r>
@@ -5860,13 +6212,13 @@
                 </a:solidFill>
                 <a:latin typeface="Calibri"/>
               </a:rPr>
-              <a:t>  •  Modelo 2 - Arbol de Decision: max_depth=5, class_weight balanceado</a:t>
+              <a:t>  •  Modelo 2: Árbol de Decisión (no lineal, max_depth = 5, class_weight = 'balanced')</a:t>
             </a:r>
           </a:p>
           <a:p>
             <a:pPr algn="l">
               <a:spcAft>
-                <a:spcPts val="1000"/>
+                <a:spcPts val="800"/>
               </a:spcAft>
             </a:pPr>
             <a:r>
@@ -5876,13 +6228,13 @@
                 </a:solidFill>
                 <a:latin typeface="Calibri"/>
               </a:rPr>
-              <a:t>  •  Metricas: accuracy, precision, recall, F1, ROC-AUC</a:t>
+              <a:t>  •  Métricas: accuracy, precision, recall, F1, ROC-AUC</a:t>
             </a:r>
           </a:p>
           <a:p>
             <a:pPr algn="l">
               <a:spcAft>
-                <a:spcPts val="1000"/>
+                <a:spcPts val="800"/>
               </a:spcAft>
             </a:pPr>
             <a:r>
@@ -5892,7 +6244,7 @@
                 </a:solidFill>
                 <a:latin typeface="Calibri"/>
               </a:rPr>
-              <a:t>  •  Validacion cruzada de 5 pliegues sobre el conjunto de entrenamiento</a:t>
+              <a:t>  •  Validación cruzada de 5 pliegues sobre el conjunto de entrenamiento</a:t>
             </a:r>
           </a:p>
         </p:txBody>
@@ -5914,17 +6266,18 @@
           <a:noFill/>
         </p:spPr>
         <p:txBody>
-          <a:bodyPr wrap="none">
+          <a:bodyPr wrap="square">
             <a:spAutoFit/>
           </a:bodyPr>
           <a:lstStyle/>
           <a:p>
             <a:pPr algn="r"/>
             <a:r>
-              <a:rPr sz="1100">
+              <a:rPr b="0" i="0" sz="1100">
                 <a:solidFill>
                   <a:srgbClr val="2E86AB"/>
                 </a:solidFill>
+                <a:latin typeface="Calibri"/>
               </a:rPr>
               <a:t>8 / 12</a:t>
             </a:r>
@@ -5973,13 +6326,13 @@
           <a:p>
             <a:pPr algn="l"/>
             <a:r>
-              <a:rPr b="1" sz="3200">
-                <a:solidFill>
-                  <a:srgbClr val="222222"/>
-                </a:solidFill>
-                <a:latin typeface="Calibri"/>
-              </a:rPr>
-              <a:t>VIII. Resultados - Matrices y ROC</a:t>
+              <a:rPr b="1" i="0" sz="3200">
+                <a:solidFill>
+                  <a:srgbClr val="2E86AB"/>
+                </a:solidFill>
+                <a:latin typeface="Calibri"/>
+              </a:rPr>
+              <a:t>Resultados: matrices y curva ROC</a:t>
             </a:r>
           </a:p>
         </p:txBody>
@@ -5993,7 +6346,7 @@
         <p:spPr>
           <a:xfrm>
             <a:off x="548640" y="1005840"/>
-            <a:ext cx="11091672" cy="777240"/>
+            <a:ext cx="11091672" cy="457200"/>
           </a:xfrm>
           <a:prstGeom prst="rect">
             <a:avLst/>
@@ -6008,13 +6361,13 @@
           <a:p>
             <a:pPr algn="l"/>
             <a:r>
-              <a:rPr b="0" sz="1800">
-                <a:solidFill>
-                  <a:srgbClr val="2E86AB"/>
-                </a:solidFill>
-                <a:latin typeface="Calibri"/>
-              </a:rPr>
-              <a:t>La Regresion Logistica clasifica mejor en ambas clases</a:t>
+              <a:rPr b="0" i="0" sz="1800">
+                <a:solidFill>
+                  <a:srgbClr val="A23B72"/>
+                </a:solidFill>
+                <a:latin typeface="Calibri"/>
+              </a:rPr>
+              <a:t>La logística clasifica mejor en ambas clases y tiene mejor AUC</a:t>
             </a:r>
           </a:p>
         </p:txBody>
@@ -6035,8 +6388,8 @@
         </p:blipFill>
         <p:spPr>
           <a:xfrm>
-            <a:off x="274320" y="1463040"/>
-            <a:ext cx="6949440" cy="2763252"/>
+            <a:off x="274320" y="1554480"/>
+            <a:ext cx="6949440" cy="2775189"/>
           </a:xfrm>
           <a:prstGeom prst="rect">
             <a:avLst/>
@@ -6059,8 +6412,8 @@
         </p:blipFill>
         <p:spPr>
           <a:xfrm>
-            <a:off x="7498079" y="1463040"/>
-            <a:ext cx="4389120" cy="3735813"/>
+            <a:off x="7498079" y="1554480"/>
+            <a:ext cx="4389120" cy="3741771"/>
           </a:xfrm>
           <a:prstGeom prst="rect">
             <a:avLst/>
@@ -6084,17 +6437,18 @@
           <a:noFill/>
         </p:spPr>
         <p:txBody>
-          <a:bodyPr wrap="none">
+          <a:bodyPr wrap="square">
             <a:spAutoFit/>
           </a:bodyPr>
           <a:lstStyle/>
           <a:p>
             <a:pPr algn="r"/>
             <a:r>
-              <a:rPr sz="1100">
+              <a:rPr b="0" i="0" sz="1100">
                 <a:solidFill>
                   <a:srgbClr val="2E86AB"/>
                 </a:solidFill>
+                <a:latin typeface="Calibri"/>
               </a:rPr>
               <a:t>9 / 12</a:t>
             </a:r>

</xml_diff>

<commit_message>
Alinear entregables con la solicitud del profesor y unificar formato
- Entregable 1: corrige el formato del notebook (texto markdown legible en
  lugar de titulos gigantes, elimina residuos) y reemplaza el Word por
  "Heart Disease UCI.docx".
- Entregable 2: reescribe el notebook con estilo explicativo en plural de
  equipo, recrea el documento Word con el formato del E1 (portada del equipo,
  estructura APA, figuras embebidas) cubriendo los topicos VI-IX, y alinea la
  presentacion a plural con el equipo en la portada.
- Redaccion humanizada y en plural en todos los artefactos.

Co-Authored-By: Claude Opus 4.7 (1M context) <noreply@anthropic.com>
</commit_message>
<xml_diff>
--- a/Entregable2/Presentacion_Sustentacion.pptx
+++ b/Entregable2/Presentacion_Sustentacion.pptx
@@ -3200,7 +3200,7 @@
                 </a:solidFill>
                 <a:latin typeface="Calibri"/>
               </a:rPr>
-              <a:t>Jaime Alzate</a:t>
+              <a:t>Jaime Alberto Alzate Marulanda · Jhon Stiven Cortes Rivera · Juan David Leyton Ruiz · Pedro Manuel Mendoza Arias · Julián Rodas González</a:t>
             </a:r>
           </a:p>
         </p:txBody>
@@ -3235,7 +3235,7 @@
                 </a:solidFill>
                 <a:latin typeface="Calibri"/>
               </a:rPr>
-              <a:t>Desarrollo de Software – 9° semestre</a:t>
+              <a:t>Desarrollo de Software, 9° semestre — Asesor: Wilson Andrés Ramírez Ríos — Institución Universitaria Pascual Bravo</a:t>
             </a:r>
           </a:p>
         </p:txBody>
@@ -4218,7 +4218,7 @@
                 </a:solidFill>
                 <a:latin typeface="Calibri"/>
               </a:rPr>
-              <a:t>Lo que aprendí y lo que haría diferente</a:t>
+              <a:t>Lo que aprendimos y lo que haríamos diferente</a:t>
             </a:r>
           </a:p>
         </p:txBody>
@@ -4257,7 +4257,7 @@
                 </a:solidFill>
                 <a:latin typeface="Calibri"/>
               </a:rPr>
-              <a:t>  •  Con PCA pude reducir de 13 a 8 variables (38% menos) y mantener el 80% de la varianza</a:t>
+              <a:t>  •  Con PCA pudimos reducir de 13 a 8 variables (38% menos) y mantener el 80% de la varianza</a:t>
             </a:r>
           </a:p>
           <a:p>
@@ -4912,7 +4912,7 @@
                 </a:solidFill>
                 <a:latin typeface="Calibri"/>
               </a:rPr>
-              <a:t>Lo que hice antes de modelar</a:t>
+              <a:t>Lo que hicimos antes de modelar</a:t>
             </a:r>
           </a:p>
         </p:txBody>
@@ -4951,7 +4951,7 @@
                 </a:solidFill>
                 <a:latin typeface="Calibri"/>
               </a:rPr>
-              <a:t>  •  Apliqué Shapiro-Wilk: ninguna de las 6 variables continuas es normal (p &lt; 0.05)</a:t>
+              <a:t>  •  Aplicamos Shapiro-Wilk: ninguna de las 6 variables continuas es normal (p &lt; 0.05)</a:t>
             </a:r>
           </a:p>
           <a:p>
@@ -4967,7 +4967,7 @@
                 </a:solidFill>
                 <a:latin typeface="Calibri"/>
               </a:rPr>
-              <a:t>  •  Encontré 6 nulos: 4 en ca y 2 en thal</a:t>
+              <a:t>  •  Encontramos 6 nulos: 4 en ca y 2 en thal</a:t>
             </a:r>
           </a:p>
           <a:p>
@@ -4999,7 +4999,7 @@
                 </a:solidFill>
                 <a:latin typeface="Calibri"/>
               </a:rPr>
-              <a:t>  •  Detecté 40 outliers con IQR, los traté con capping para no perder filas</a:t>
+              <a:t>  •  Detectamos 40 outliers con IQR, los traté con capping para no perder filas</a:t>
             </a:r>
           </a:p>
           <a:p>
@@ -5015,7 +5015,7 @@
                 </a:solidFill>
                 <a:latin typeface="Calibri"/>
               </a:rPr>
-              <a:t>  •  Comparé imputación por mediana vs por regresión bayesiana → me quedé con la segunda</a:t>
+              <a:t>  •  Comparamos imputación por mediana vs por regresión bayesiana → me quedé con la segunda</a:t>
             </a:r>
           </a:p>
         </p:txBody>
@@ -5103,7 +5103,7 @@
                 </a:solidFill>
                 <a:latin typeface="Calibri"/>
               </a:rPr>
-              <a:t>PCA: ¿cuántos componentes necesito?</a:t>
+              <a:t>PCA: ¿cuántos componentes necesitamos?</a:t>
             </a:r>
           </a:p>
         </p:txBody>
@@ -5138,7 +5138,7 @@
                 </a:solidFill>
                 <a:latin typeface="Calibri"/>
               </a:rPr>
-              <a:t>Con 8 componentes ya tengo el 80% de la varianza</a:t>
+              <a:t>Con 8 componentes ya tenemos el 80% de la varianza</a:t>
             </a:r>
           </a:p>
         </p:txBody>
@@ -5285,7 +5285,7 @@
                 </a:solidFill>
                 <a:latin typeface="Calibri"/>
               </a:rPr>
-              <a:t>Mirando las cargas le encontré sentido a los 2 primeros</a:t>
+              <a:t>Mirando las cargas le encontramos sentido a los 2 primeros</a:t>
             </a:r>
           </a:p>
         </p:txBody>
@@ -6106,7 +6106,7 @@
                 </a:solidFill>
                 <a:latin typeface="Calibri"/>
               </a:rPr>
-              <a:t>Los dos modelos que comparé</a:t>
+              <a:t>Los dos modelos que comparamos</a:t>
             </a:r>
           </a:p>
         </p:txBody>
@@ -6141,7 +6141,7 @@
                 </a:solidFill>
                 <a:latin typeface="Calibri"/>
               </a:rPr>
-              <a:t>Escogí los dos primeros ejemplos que pone el profesor en la rúbrica</a:t>
+              <a:t>Escogimos los dos primeros ejemplos que pone el profesor en la rúbrica</a:t>
             </a:r>
           </a:p>
         </p:txBody>

</xml_diff>